<commit_message>
Add company logo PNGs to backup one-pagers
Render official brand marks from the simple-icons set to 512px black PNGs
(assets/logos/) and place each at the top right of its backup one-pager.
The generator skips the logo gracefully when the PNG is absent; Plaid's
mark is not distributed through any reachable source, so its one-pager
ships without a logo until assets/logos/plaid.png is provided.

Co-Authored-By: Claude Fable 5 <noreply@anthropic.com>
Claude-Session: https://claude.ai/code/session_0126N96cQHaux6R4tR5ZNnVx
</commit_message>
<xml_diff>
--- a/Forward-Deployed-Engineering_Executive-Deck.pptx
+++ b/Forward-Deployed-Engineering_Executive-Deck.pptx
@@ -4504,7 +4504,7 @@
         <p:spPr>
           <a:xfrm>
             <a:off x="502920" y="292608"/>
-            <a:ext cx="11185855" cy="685800"/>
+            <a:ext cx="10408615" cy="685800"/>
           </a:xfrm>
           <a:prstGeom prst="rect">
             <a:avLst/>
@@ -4537,9 +4537,33 @@
           </a:p>
         </p:txBody>
       </p:sp>
+      <p:pic>
+        <p:nvPicPr>
+          <p:cNvPr id="3" name="Picture 2" descr="stripe.png"/>
+          <p:cNvPicPr>
+            <a:picLocks noChangeAspect="1"/>
+          </p:cNvPicPr>
+          <p:nvPr/>
+        </p:nvPicPr>
+        <p:blipFill>
+          <a:blip r:embed="rId2"/>
+          <a:stretch>
+            <a:fillRect/>
+          </a:stretch>
+        </p:blipFill>
+        <p:spPr>
+          <a:xfrm>
+            <a:off x="11231575" y="274320"/>
+            <a:ext cx="457200" cy="457200"/>
+          </a:xfrm>
+          <a:prstGeom prst="rect">
+            <a:avLst/>
+          </a:prstGeom>
+        </p:spPr>
+      </p:pic>
       <p:cxnSp>
         <p:nvCxnSpPr>
-          <p:cNvPr id="3" name="Connector 2"/>
+          <p:cNvPr id="4" name="Connector 3"/>
           <p:cNvCxnSpPr/>
           <p:nvPr/>
         </p:nvCxnSpPr>
@@ -4561,7 +4585,7 @@
       </p:cxnSp>
       <p:sp>
         <p:nvSpPr>
-          <p:cNvPr id="4" name="TextBox 3"/>
+          <p:cNvPr id="5" name="TextBox 4"/>
           <p:cNvSpPr txBox="1"/>
           <p:nvPr/>
         </p:nvSpPr>
@@ -4603,7 +4627,7 @@
       </p:sp>
       <p:sp>
         <p:nvSpPr>
-          <p:cNvPr id="5" name="TextBox 4"/>
+          <p:cNvPr id="6" name="TextBox 5"/>
           <p:cNvSpPr txBox="1"/>
           <p:nvPr/>
         </p:nvSpPr>
@@ -4645,7 +4669,7 @@
       </p:sp>
       <p:cxnSp>
         <p:nvCxnSpPr>
-          <p:cNvPr id="6" name="Connector 5"/>
+          <p:cNvPr id="7" name="Connector 6"/>
           <p:cNvCxnSpPr/>
           <p:nvPr/>
         </p:nvCxnSpPr>
@@ -4667,7 +4691,7 @@
       </p:cxnSp>
       <p:sp>
         <p:nvSpPr>
-          <p:cNvPr id="7" name="TextBox 6"/>
+          <p:cNvPr id="8" name="TextBox 7"/>
           <p:cNvSpPr txBox="1"/>
           <p:nvPr/>
         </p:nvSpPr>
@@ -4774,7 +4798,7 @@
       </p:sp>
       <p:sp>
         <p:nvSpPr>
-          <p:cNvPr id="8" name="TextBox 7"/>
+          <p:cNvPr id="9" name="TextBox 8"/>
           <p:cNvSpPr txBox="1"/>
           <p:nvPr/>
         </p:nvSpPr>
@@ -4816,7 +4840,7 @@
       </p:sp>
       <p:cxnSp>
         <p:nvCxnSpPr>
-          <p:cNvPr id="9" name="Connector 8"/>
+          <p:cNvPr id="10" name="Connector 9"/>
           <p:cNvCxnSpPr/>
           <p:nvPr/>
         </p:nvCxnSpPr>
@@ -4838,7 +4862,7 @@
       </p:cxnSp>
       <p:sp>
         <p:nvSpPr>
-          <p:cNvPr id="10" name="TextBox 9"/>
+          <p:cNvPr id="11" name="TextBox 10"/>
           <p:cNvSpPr txBox="1"/>
           <p:nvPr/>
         </p:nvSpPr>
@@ -4917,7 +4941,7 @@
       </p:sp>
       <p:sp>
         <p:nvSpPr>
-          <p:cNvPr id="11" name="TextBox 10"/>
+          <p:cNvPr id="12" name="TextBox 11"/>
           <p:cNvSpPr txBox="1"/>
           <p:nvPr/>
         </p:nvSpPr>
@@ -4959,7 +4983,7 @@
       </p:sp>
       <p:cxnSp>
         <p:nvCxnSpPr>
-          <p:cNvPr id="12" name="Connector 11"/>
+          <p:cNvPr id="13" name="Connector 12"/>
           <p:cNvCxnSpPr/>
           <p:nvPr/>
         </p:nvCxnSpPr>
@@ -4981,7 +5005,7 @@
       </p:cxnSp>
       <p:sp>
         <p:nvSpPr>
-          <p:cNvPr id="13" name="TextBox 12"/>
+          <p:cNvPr id="14" name="TextBox 13"/>
           <p:cNvSpPr txBox="1"/>
           <p:nvPr/>
         </p:nvSpPr>
@@ -5060,7 +5084,7 @@
       </p:sp>
       <p:sp>
         <p:nvSpPr>
-          <p:cNvPr id="14" name="TextBox 13"/>
+          <p:cNvPr id="15" name="TextBox 14"/>
           <p:cNvSpPr txBox="1"/>
           <p:nvPr/>
         </p:nvSpPr>
@@ -5102,7 +5126,7 @@
       </p:sp>
       <p:cxnSp>
         <p:nvCxnSpPr>
-          <p:cNvPr id="15" name="Connector 14"/>
+          <p:cNvPr id="16" name="Connector 15"/>
           <p:cNvCxnSpPr/>
           <p:nvPr/>
         </p:nvCxnSpPr>
@@ -5124,7 +5148,7 @@
       </p:cxnSp>
       <p:sp>
         <p:nvSpPr>
-          <p:cNvPr id="16" name="TextBox 15"/>
+          <p:cNvPr id="17" name="TextBox 16"/>
           <p:cNvSpPr txBox="1"/>
           <p:nvPr/>
         </p:nvSpPr>
@@ -5203,7 +5227,7 @@
       </p:sp>
       <p:cxnSp>
         <p:nvCxnSpPr>
-          <p:cNvPr id="17" name="Connector 16"/>
+          <p:cNvPr id="18" name="Connector 17"/>
           <p:cNvCxnSpPr/>
           <p:nvPr/>
         </p:nvCxnSpPr>
@@ -5225,7 +5249,7 @@
       </p:cxnSp>
       <p:sp>
         <p:nvSpPr>
-          <p:cNvPr id="18" name="TextBox 17"/>
+          <p:cNvPr id="19" name="TextBox 18"/>
           <p:cNvSpPr txBox="1"/>
           <p:nvPr/>
         </p:nvSpPr>
@@ -5267,7 +5291,7 @@
       </p:sp>
       <p:sp>
         <p:nvSpPr>
-          <p:cNvPr id="19" name="TextBox 18"/>
+          <p:cNvPr id="20" name="TextBox 19"/>
           <p:cNvSpPr txBox="1"/>
           <p:nvPr/>
         </p:nvSpPr>
@@ -5334,7 +5358,7 @@
         <p:spPr>
           <a:xfrm>
             <a:off x="502920" y="292608"/>
-            <a:ext cx="11185855" cy="685800"/>
+            <a:ext cx="10408615" cy="685800"/>
           </a:xfrm>
           <a:prstGeom prst="rect">
             <a:avLst/>
@@ -5367,9 +5391,33 @@
           </a:p>
         </p:txBody>
       </p:sp>
+      <p:pic>
+        <p:nvPicPr>
+          <p:cNvPr id="3" name="Picture 2" descr="brex.png"/>
+          <p:cNvPicPr>
+            <a:picLocks noChangeAspect="1"/>
+          </p:cNvPicPr>
+          <p:nvPr/>
+        </p:nvPicPr>
+        <p:blipFill>
+          <a:blip r:embed="rId2"/>
+          <a:stretch>
+            <a:fillRect/>
+          </a:stretch>
+        </p:blipFill>
+        <p:spPr>
+          <a:xfrm>
+            <a:off x="11231575" y="274320"/>
+            <a:ext cx="457200" cy="457200"/>
+          </a:xfrm>
+          <a:prstGeom prst="rect">
+            <a:avLst/>
+          </a:prstGeom>
+        </p:spPr>
+      </p:pic>
       <p:cxnSp>
         <p:nvCxnSpPr>
-          <p:cNvPr id="3" name="Connector 2"/>
+          <p:cNvPr id="4" name="Connector 3"/>
           <p:cNvCxnSpPr/>
           <p:nvPr/>
         </p:nvCxnSpPr>
@@ -5391,7 +5439,7 @@
       </p:cxnSp>
       <p:sp>
         <p:nvSpPr>
-          <p:cNvPr id="4" name="TextBox 3"/>
+          <p:cNvPr id="5" name="TextBox 4"/>
           <p:cNvSpPr txBox="1"/>
           <p:nvPr/>
         </p:nvSpPr>
@@ -5433,7 +5481,7 @@
       </p:sp>
       <p:sp>
         <p:nvSpPr>
-          <p:cNvPr id="5" name="TextBox 4"/>
+          <p:cNvPr id="6" name="TextBox 5"/>
           <p:cNvSpPr txBox="1"/>
           <p:nvPr/>
         </p:nvSpPr>
@@ -5475,7 +5523,7 @@
       </p:sp>
       <p:cxnSp>
         <p:nvCxnSpPr>
-          <p:cNvPr id="6" name="Connector 5"/>
+          <p:cNvPr id="7" name="Connector 6"/>
           <p:cNvCxnSpPr/>
           <p:nvPr/>
         </p:nvCxnSpPr>
@@ -5497,7 +5545,7 @@
       </p:cxnSp>
       <p:sp>
         <p:nvSpPr>
-          <p:cNvPr id="7" name="TextBox 6"/>
+          <p:cNvPr id="8" name="TextBox 7"/>
           <p:cNvSpPr txBox="1"/>
           <p:nvPr/>
         </p:nvSpPr>
@@ -5604,7 +5652,7 @@
       </p:sp>
       <p:sp>
         <p:nvSpPr>
-          <p:cNvPr id="8" name="TextBox 7"/>
+          <p:cNvPr id="9" name="TextBox 8"/>
           <p:cNvSpPr txBox="1"/>
           <p:nvPr/>
         </p:nvSpPr>
@@ -5646,7 +5694,7 @@
       </p:sp>
       <p:cxnSp>
         <p:nvCxnSpPr>
-          <p:cNvPr id="9" name="Connector 8"/>
+          <p:cNvPr id="10" name="Connector 9"/>
           <p:cNvCxnSpPr/>
           <p:nvPr/>
         </p:nvCxnSpPr>
@@ -5668,7 +5716,7 @@
       </p:cxnSp>
       <p:sp>
         <p:nvSpPr>
-          <p:cNvPr id="10" name="TextBox 9"/>
+          <p:cNvPr id="11" name="TextBox 10"/>
           <p:cNvSpPr txBox="1"/>
           <p:nvPr/>
         </p:nvSpPr>
@@ -5747,7 +5795,7 @@
       </p:sp>
       <p:sp>
         <p:nvSpPr>
-          <p:cNvPr id="11" name="TextBox 10"/>
+          <p:cNvPr id="12" name="TextBox 11"/>
           <p:cNvSpPr txBox="1"/>
           <p:nvPr/>
         </p:nvSpPr>
@@ -5789,7 +5837,7 @@
       </p:sp>
       <p:cxnSp>
         <p:nvCxnSpPr>
-          <p:cNvPr id="12" name="Connector 11"/>
+          <p:cNvPr id="13" name="Connector 12"/>
           <p:cNvCxnSpPr/>
           <p:nvPr/>
         </p:nvCxnSpPr>
@@ -5811,7 +5859,7 @@
       </p:cxnSp>
       <p:sp>
         <p:nvSpPr>
-          <p:cNvPr id="13" name="TextBox 12"/>
+          <p:cNvPr id="14" name="TextBox 13"/>
           <p:cNvSpPr txBox="1"/>
           <p:nvPr/>
         </p:nvSpPr>
@@ -5890,7 +5938,7 @@
       </p:sp>
       <p:sp>
         <p:nvSpPr>
-          <p:cNvPr id="14" name="TextBox 13"/>
+          <p:cNvPr id="15" name="TextBox 14"/>
           <p:cNvSpPr txBox="1"/>
           <p:nvPr/>
         </p:nvSpPr>
@@ -5932,7 +5980,7 @@
       </p:sp>
       <p:cxnSp>
         <p:nvCxnSpPr>
-          <p:cNvPr id="15" name="Connector 14"/>
+          <p:cNvPr id="16" name="Connector 15"/>
           <p:cNvCxnSpPr/>
           <p:nvPr/>
         </p:nvCxnSpPr>
@@ -5954,7 +6002,7 @@
       </p:cxnSp>
       <p:sp>
         <p:nvSpPr>
-          <p:cNvPr id="16" name="TextBox 15"/>
+          <p:cNvPr id="17" name="TextBox 16"/>
           <p:cNvSpPr txBox="1"/>
           <p:nvPr/>
         </p:nvSpPr>
@@ -6033,7 +6081,7 @@
       </p:sp>
       <p:cxnSp>
         <p:nvCxnSpPr>
-          <p:cNvPr id="17" name="Connector 16"/>
+          <p:cNvPr id="18" name="Connector 17"/>
           <p:cNvCxnSpPr/>
           <p:nvPr/>
         </p:nvCxnSpPr>
@@ -6055,7 +6103,7 @@
       </p:cxnSp>
       <p:sp>
         <p:nvSpPr>
-          <p:cNvPr id="18" name="TextBox 17"/>
+          <p:cNvPr id="19" name="TextBox 18"/>
           <p:cNvSpPr txBox="1"/>
           <p:nvPr/>
         </p:nvSpPr>
@@ -6097,7 +6145,7 @@
       </p:sp>
       <p:sp>
         <p:nvSpPr>
-          <p:cNvPr id="19" name="TextBox 18"/>
+          <p:cNvPr id="20" name="TextBox 19"/>
           <p:cNvSpPr txBox="1"/>
           <p:nvPr/>
         </p:nvSpPr>
@@ -12470,7 +12518,7 @@
         <p:spPr>
           <a:xfrm>
             <a:off x="502920" y="292608"/>
-            <a:ext cx="11185855" cy="685800"/>
+            <a:ext cx="10408615" cy="685800"/>
           </a:xfrm>
           <a:prstGeom prst="rect">
             <a:avLst/>
@@ -12503,9 +12551,33 @@
           </a:p>
         </p:txBody>
       </p:sp>
+      <p:pic>
+        <p:nvPicPr>
+          <p:cNvPr id="3" name="Picture 2" descr="palantir.png"/>
+          <p:cNvPicPr>
+            <a:picLocks noChangeAspect="1"/>
+          </p:cNvPicPr>
+          <p:nvPr/>
+        </p:nvPicPr>
+        <p:blipFill>
+          <a:blip r:embed="rId2"/>
+          <a:stretch>
+            <a:fillRect/>
+          </a:stretch>
+        </p:blipFill>
+        <p:spPr>
+          <a:xfrm>
+            <a:off x="11231575" y="274320"/>
+            <a:ext cx="457200" cy="457200"/>
+          </a:xfrm>
+          <a:prstGeom prst="rect">
+            <a:avLst/>
+          </a:prstGeom>
+        </p:spPr>
+      </p:pic>
       <p:cxnSp>
         <p:nvCxnSpPr>
-          <p:cNvPr id="3" name="Connector 2"/>
+          <p:cNvPr id="4" name="Connector 3"/>
           <p:cNvCxnSpPr/>
           <p:nvPr/>
         </p:nvCxnSpPr>
@@ -12527,7 +12599,7 @@
       </p:cxnSp>
       <p:sp>
         <p:nvSpPr>
-          <p:cNvPr id="4" name="TextBox 3"/>
+          <p:cNvPr id="5" name="TextBox 4"/>
           <p:cNvSpPr txBox="1"/>
           <p:nvPr/>
         </p:nvSpPr>
@@ -12569,7 +12641,7 @@
       </p:sp>
       <p:sp>
         <p:nvSpPr>
-          <p:cNvPr id="5" name="TextBox 4"/>
+          <p:cNvPr id="6" name="TextBox 5"/>
           <p:cNvSpPr txBox="1"/>
           <p:nvPr/>
         </p:nvSpPr>
@@ -12611,7 +12683,7 @@
       </p:sp>
       <p:cxnSp>
         <p:nvCxnSpPr>
-          <p:cNvPr id="6" name="Connector 5"/>
+          <p:cNvPr id="7" name="Connector 6"/>
           <p:cNvCxnSpPr/>
           <p:nvPr/>
         </p:nvCxnSpPr>
@@ -12633,7 +12705,7 @@
       </p:cxnSp>
       <p:sp>
         <p:nvSpPr>
-          <p:cNvPr id="7" name="TextBox 6"/>
+          <p:cNvPr id="8" name="TextBox 7"/>
           <p:cNvSpPr txBox="1"/>
           <p:nvPr/>
         </p:nvSpPr>
@@ -12768,7 +12840,7 @@
       </p:sp>
       <p:sp>
         <p:nvSpPr>
-          <p:cNvPr id="8" name="TextBox 7"/>
+          <p:cNvPr id="9" name="TextBox 8"/>
           <p:cNvSpPr txBox="1"/>
           <p:nvPr/>
         </p:nvSpPr>
@@ -12810,7 +12882,7 @@
       </p:sp>
       <p:cxnSp>
         <p:nvCxnSpPr>
-          <p:cNvPr id="9" name="Connector 8"/>
+          <p:cNvPr id="10" name="Connector 9"/>
           <p:cNvCxnSpPr/>
           <p:nvPr/>
         </p:nvCxnSpPr>
@@ -12832,7 +12904,7 @@
       </p:cxnSp>
       <p:sp>
         <p:nvSpPr>
-          <p:cNvPr id="10" name="TextBox 9"/>
+          <p:cNvPr id="11" name="TextBox 10"/>
           <p:cNvSpPr txBox="1"/>
           <p:nvPr/>
         </p:nvSpPr>
@@ -12939,7 +13011,7 @@
       </p:sp>
       <p:sp>
         <p:nvSpPr>
-          <p:cNvPr id="11" name="TextBox 10"/>
+          <p:cNvPr id="12" name="TextBox 11"/>
           <p:cNvSpPr txBox="1"/>
           <p:nvPr/>
         </p:nvSpPr>
@@ -12981,7 +13053,7 @@
       </p:sp>
       <p:cxnSp>
         <p:nvCxnSpPr>
-          <p:cNvPr id="12" name="Connector 11"/>
+          <p:cNvPr id="13" name="Connector 12"/>
           <p:cNvCxnSpPr/>
           <p:nvPr/>
         </p:nvCxnSpPr>
@@ -13003,7 +13075,7 @@
       </p:cxnSp>
       <p:sp>
         <p:nvSpPr>
-          <p:cNvPr id="13" name="TextBox 12"/>
+          <p:cNvPr id="14" name="TextBox 13"/>
           <p:cNvSpPr txBox="1"/>
           <p:nvPr/>
         </p:nvSpPr>
@@ -13110,7 +13182,7 @@
       </p:sp>
       <p:sp>
         <p:nvSpPr>
-          <p:cNvPr id="14" name="TextBox 13"/>
+          <p:cNvPr id="15" name="TextBox 14"/>
           <p:cNvSpPr txBox="1"/>
           <p:nvPr/>
         </p:nvSpPr>
@@ -13152,7 +13224,7 @@
       </p:sp>
       <p:cxnSp>
         <p:nvCxnSpPr>
-          <p:cNvPr id="15" name="Connector 14"/>
+          <p:cNvPr id="16" name="Connector 15"/>
           <p:cNvCxnSpPr/>
           <p:nvPr/>
         </p:nvCxnSpPr>
@@ -13174,7 +13246,7 @@
       </p:cxnSp>
       <p:sp>
         <p:nvSpPr>
-          <p:cNvPr id="16" name="TextBox 15"/>
+          <p:cNvPr id="17" name="TextBox 16"/>
           <p:cNvSpPr txBox="1"/>
           <p:nvPr/>
         </p:nvSpPr>
@@ -13281,7 +13353,7 @@
       </p:sp>
       <p:cxnSp>
         <p:nvCxnSpPr>
-          <p:cNvPr id="17" name="Connector 16"/>
+          <p:cNvPr id="18" name="Connector 17"/>
           <p:cNvCxnSpPr/>
           <p:nvPr/>
         </p:nvCxnSpPr>
@@ -13303,7 +13375,7 @@
       </p:cxnSp>
       <p:sp>
         <p:nvSpPr>
-          <p:cNvPr id="18" name="TextBox 17"/>
+          <p:cNvPr id="19" name="TextBox 18"/>
           <p:cNvSpPr txBox="1"/>
           <p:nvPr/>
         </p:nvSpPr>
@@ -13345,7 +13417,7 @@
       </p:sp>
       <p:sp>
         <p:nvSpPr>
-          <p:cNvPr id="19" name="TextBox 18"/>
+          <p:cNvPr id="20" name="TextBox 19"/>
           <p:cNvSpPr txBox="1"/>
           <p:nvPr/>
         </p:nvSpPr>
@@ -13412,7 +13484,7 @@
         <p:spPr>
           <a:xfrm>
             <a:off x="502920" y="292608"/>
-            <a:ext cx="11185855" cy="685800"/>
+            <a:ext cx="10408615" cy="685800"/>
           </a:xfrm>
           <a:prstGeom prst="rect">
             <a:avLst/>
@@ -13445,9 +13517,33 @@
           </a:p>
         </p:txBody>
       </p:sp>
+      <p:pic>
+        <p:nvPicPr>
+          <p:cNvPr id="3" name="Picture 2" descr="uber.png"/>
+          <p:cNvPicPr>
+            <a:picLocks noChangeAspect="1"/>
+          </p:cNvPicPr>
+          <p:nvPr/>
+        </p:nvPicPr>
+        <p:blipFill>
+          <a:blip r:embed="rId2"/>
+          <a:stretch>
+            <a:fillRect/>
+          </a:stretch>
+        </p:blipFill>
+        <p:spPr>
+          <a:xfrm>
+            <a:off x="11231575" y="274320"/>
+            <a:ext cx="457200" cy="457200"/>
+          </a:xfrm>
+          <a:prstGeom prst="rect">
+            <a:avLst/>
+          </a:prstGeom>
+        </p:spPr>
+      </p:pic>
       <p:cxnSp>
         <p:nvCxnSpPr>
-          <p:cNvPr id="3" name="Connector 2"/>
+          <p:cNvPr id="4" name="Connector 3"/>
           <p:cNvCxnSpPr/>
           <p:nvPr/>
         </p:nvCxnSpPr>
@@ -13469,7 +13565,7 @@
       </p:cxnSp>
       <p:sp>
         <p:nvSpPr>
-          <p:cNvPr id="4" name="TextBox 3"/>
+          <p:cNvPr id="5" name="TextBox 4"/>
           <p:cNvSpPr txBox="1"/>
           <p:nvPr/>
         </p:nvSpPr>
@@ -13511,7 +13607,7 @@
       </p:sp>
       <p:sp>
         <p:nvSpPr>
-          <p:cNvPr id="5" name="TextBox 4"/>
+          <p:cNvPr id="6" name="TextBox 5"/>
           <p:cNvSpPr txBox="1"/>
           <p:nvPr/>
         </p:nvSpPr>
@@ -13553,7 +13649,7 @@
       </p:sp>
       <p:cxnSp>
         <p:nvCxnSpPr>
-          <p:cNvPr id="6" name="Connector 5"/>
+          <p:cNvPr id="7" name="Connector 6"/>
           <p:cNvCxnSpPr/>
           <p:nvPr/>
         </p:nvCxnSpPr>
@@ -13575,7 +13671,7 @@
       </p:cxnSp>
       <p:sp>
         <p:nvSpPr>
-          <p:cNvPr id="7" name="TextBox 6"/>
+          <p:cNvPr id="8" name="TextBox 7"/>
           <p:cNvSpPr txBox="1"/>
           <p:nvPr/>
         </p:nvSpPr>
@@ -13682,7 +13778,7 @@
       </p:sp>
       <p:sp>
         <p:nvSpPr>
-          <p:cNvPr id="8" name="TextBox 7"/>
+          <p:cNvPr id="9" name="TextBox 8"/>
           <p:cNvSpPr txBox="1"/>
           <p:nvPr/>
         </p:nvSpPr>
@@ -13724,7 +13820,7 @@
       </p:sp>
       <p:cxnSp>
         <p:nvCxnSpPr>
-          <p:cNvPr id="9" name="Connector 8"/>
+          <p:cNvPr id="10" name="Connector 9"/>
           <p:cNvCxnSpPr/>
           <p:nvPr/>
         </p:nvCxnSpPr>
@@ -13746,7 +13842,7 @@
       </p:cxnSp>
       <p:sp>
         <p:nvSpPr>
-          <p:cNvPr id="10" name="TextBox 9"/>
+          <p:cNvPr id="11" name="TextBox 10"/>
           <p:cNvSpPr txBox="1"/>
           <p:nvPr/>
         </p:nvSpPr>
@@ -13853,7 +13949,7 @@
       </p:sp>
       <p:sp>
         <p:nvSpPr>
-          <p:cNvPr id="11" name="TextBox 10"/>
+          <p:cNvPr id="12" name="TextBox 11"/>
           <p:cNvSpPr txBox="1"/>
           <p:nvPr/>
         </p:nvSpPr>
@@ -13895,7 +13991,7 @@
       </p:sp>
       <p:cxnSp>
         <p:nvCxnSpPr>
-          <p:cNvPr id="12" name="Connector 11"/>
+          <p:cNvPr id="13" name="Connector 12"/>
           <p:cNvCxnSpPr/>
           <p:nvPr/>
         </p:nvCxnSpPr>
@@ -13917,7 +14013,7 @@
       </p:cxnSp>
       <p:sp>
         <p:nvSpPr>
-          <p:cNvPr id="13" name="TextBox 12"/>
+          <p:cNvPr id="14" name="TextBox 13"/>
           <p:cNvSpPr txBox="1"/>
           <p:nvPr/>
         </p:nvSpPr>
@@ -14024,7 +14120,7 @@
       </p:sp>
       <p:sp>
         <p:nvSpPr>
-          <p:cNvPr id="14" name="TextBox 13"/>
+          <p:cNvPr id="15" name="TextBox 14"/>
           <p:cNvSpPr txBox="1"/>
           <p:nvPr/>
         </p:nvSpPr>
@@ -14066,7 +14162,7 @@
       </p:sp>
       <p:cxnSp>
         <p:nvCxnSpPr>
-          <p:cNvPr id="15" name="Connector 14"/>
+          <p:cNvPr id="16" name="Connector 15"/>
           <p:cNvCxnSpPr/>
           <p:nvPr/>
         </p:nvCxnSpPr>
@@ -14088,7 +14184,7 @@
       </p:cxnSp>
       <p:sp>
         <p:nvSpPr>
-          <p:cNvPr id="16" name="TextBox 15"/>
+          <p:cNvPr id="17" name="TextBox 16"/>
           <p:cNvSpPr txBox="1"/>
           <p:nvPr/>
         </p:nvSpPr>
@@ -14195,7 +14291,7 @@
       </p:sp>
       <p:cxnSp>
         <p:nvCxnSpPr>
-          <p:cNvPr id="17" name="Connector 16"/>
+          <p:cNvPr id="18" name="Connector 17"/>
           <p:cNvCxnSpPr/>
           <p:nvPr/>
         </p:nvCxnSpPr>
@@ -14217,7 +14313,7 @@
       </p:cxnSp>
       <p:sp>
         <p:nvSpPr>
-          <p:cNvPr id="18" name="TextBox 17"/>
+          <p:cNvPr id="19" name="TextBox 18"/>
           <p:cNvSpPr txBox="1"/>
           <p:nvPr/>
         </p:nvSpPr>
@@ -14259,7 +14355,7 @@
       </p:sp>
       <p:sp>
         <p:nvSpPr>
-          <p:cNvPr id="19" name="TextBox 18"/>
+          <p:cNvPr id="20" name="TextBox 19"/>
           <p:cNvSpPr txBox="1"/>
           <p:nvPr/>
         </p:nvSpPr>
@@ -14326,7 +14422,7 @@
         <p:spPr>
           <a:xfrm>
             <a:off x="502920" y="292608"/>
-            <a:ext cx="11185855" cy="685800"/>
+            <a:ext cx="10408615" cy="685800"/>
           </a:xfrm>
           <a:prstGeom prst="rect">
             <a:avLst/>
@@ -14359,9 +14455,33 @@
           </a:p>
         </p:txBody>
       </p:sp>
+      <p:pic>
+        <p:nvPicPr>
+          <p:cNvPr id="3" name="Picture 2" descr="openai.png"/>
+          <p:cNvPicPr>
+            <a:picLocks noChangeAspect="1"/>
+          </p:cNvPicPr>
+          <p:nvPr/>
+        </p:nvPicPr>
+        <p:blipFill>
+          <a:blip r:embed="rId2"/>
+          <a:stretch>
+            <a:fillRect/>
+          </a:stretch>
+        </p:blipFill>
+        <p:spPr>
+          <a:xfrm>
+            <a:off x="11231575" y="274320"/>
+            <a:ext cx="457200" cy="457200"/>
+          </a:xfrm>
+          <a:prstGeom prst="rect">
+            <a:avLst/>
+          </a:prstGeom>
+        </p:spPr>
+      </p:pic>
       <p:cxnSp>
         <p:nvCxnSpPr>
-          <p:cNvPr id="3" name="Connector 2"/>
+          <p:cNvPr id="4" name="Connector 3"/>
           <p:cNvCxnSpPr/>
           <p:nvPr/>
         </p:nvCxnSpPr>
@@ -14383,7 +14503,7 @@
       </p:cxnSp>
       <p:sp>
         <p:nvSpPr>
-          <p:cNvPr id="4" name="TextBox 3"/>
+          <p:cNvPr id="5" name="TextBox 4"/>
           <p:cNvSpPr txBox="1"/>
           <p:nvPr/>
         </p:nvSpPr>
@@ -14425,7 +14545,7 @@
       </p:sp>
       <p:sp>
         <p:nvSpPr>
-          <p:cNvPr id="5" name="TextBox 4"/>
+          <p:cNvPr id="6" name="TextBox 5"/>
           <p:cNvSpPr txBox="1"/>
           <p:nvPr/>
         </p:nvSpPr>
@@ -14467,7 +14587,7 @@
       </p:sp>
       <p:cxnSp>
         <p:nvCxnSpPr>
-          <p:cNvPr id="6" name="Connector 5"/>
+          <p:cNvPr id="7" name="Connector 6"/>
           <p:cNvCxnSpPr/>
           <p:nvPr/>
         </p:nvCxnSpPr>
@@ -14489,7 +14609,7 @@
       </p:cxnSp>
       <p:sp>
         <p:nvSpPr>
-          <p:cNvPr id="7" name="TextBox 6"/>
+          <p:cNvPr id="8" name="TextBox 7"/>
           <p:cNvSpPr txBox="1"/>
           <p:nvPr/>
         </p:nvSpPr>
@@ -14596,7 +14716,7 @@
       </p:sp>
       <p:sp>
         <p:nvSpPr>
-          <p:cNvPr id="8" name="TextBox 7"/>
+          <p:cNvPr id="9" name="TextBox 8"/>
           <p:cNvSpPr txBox="1"/>
           <p:nvPr/>
         </p:nvSpPr>
@@ -14638,7 +14758,7 @@
       </p:sp>
       <p:cxnSp>
         <p:nvCxnSpPr>
-          <p:cNvPr id="9" name="Connector 8"/>
+          <p:cNvPr id="10" name="Connector 9"/>
           <p:cNvCxnSpPr/>
           <p:nvPr/>
         </p:nvCxnSpPr>
@@ -14660,7 +14780,7 @@
       </p:cxnSp>
       <p:sp>
         <p:nvSpPr>
-          <p:cNvPr id="10" name="TextBox 9"/>
+          <p:cNvPr id="11" name="TextBox 10"/>
           <p:cNvSpPr txBox="1"/>
           <p:nvPr/>
         </p:nvSpPr>
@@ -14767,7 +14887,7 @@
       </p:sp>
       <p:sp>
         <p:nvSpPr>
-          <p:cNvPr id="11" name="TextBox 10"/>
+          <p:cNvPr id="12" name="TextBox 11"/>
           <p:cNvSpPr txBox="1"/>
           <p:nvPr/>
         </p:nvSpPr>
@@ -14809,7 +14929,7 @@
       </p:sp>
       <p:cxnSp>
         <p:nvCxnSpPr>
-          <p:cNvPr id="12" name="Connector 11"/>
+          <p:cNvPr id="13" name="Connector 12"/>
           <p:cNvCxnSpPr/>
           <p:nvPr/>
         </p:nvCxnSpPr>
@@ -14831,7 +14951,7 @@
       </p:cxnSp>
       <p:sp>
         <p:nvSpPr>
-          <p:cNvPr id="13" name="TextBox 12"/>
+          <p:cNvPr id="14" name="TextBox 13"/>
           <p:cNvSpPr txBox="1"/>
           <p:nvPr/>
         </p:nvSpPr>
@@ -14938,7 +15058,7 @@
       </p:sp>
       <p:sp>
         <p:nvSpPr>
-          <p:cNvPr id="14" name="TextBox 13"/>
+          <p:cNvPr id="15" name="TextBox 14"/>
           <p:cNvSpPr txBox="1"/>
           <p:nvPr/>
         </p:nvSpPr>
@@ -14980,7 +15100,7 @@
       </p:sp>
       <p:cxnSp>
         <p:nvCxnSpPr>
-          <p:cNvPr id="15" name="Connector 14"/>
+          <p:cNvPr id="16" name="Connector 15"/>
           <p:cNvCxnSpPr/>
           <p:nvPr/>
         </p:nvCxnSpPr>
@@ -15002,7 +15122,7 @@
       </p:cxnSp>
       <p:sp>
         <p:nvSpPr>
-          <p:cNvPr id="16" name="TextBox 15"/>
+          <p:cNvPr id="17" name="TextBox 16"/>
           <p:cNvSpPr txBox="1"/>
           <p:nvPr/>
         </p:nvSpPr>
@@ -15081,7 +15201,7 @@
       </p:sp>
       <p:cxnSp>
         <p:nvCxnSpPr>
-          <p:cNvPr id="17" name="Connector 16"/>
+          <p:cNvPr id="18" name="Connector 17"/>
           <p:cNvCxnSpPr/>
           <p:nvPr/>
         </p:nvCxnSpPr>
@@ -15103,7 +15223,7 @@
       </p:cxnSp>
       <p:sp>
         <p:nvSpPr>
-          <p:cNvPr id="18" name="TextBox 17"/>
+          <p:cNvPr id="19" name="TextBox 18"/>
           <p:cNvSpPr txBox="1"/>
           <p:nvPr/>
         </p:nvSpPr>
@@ -15145,7 +15265,7 @@
       </p:sp>
       <p:sp>
         <p:nvSpPr>
-          <p:cNvPr id="19" name="TextBox 18"/>
+          <p:cNvPr id="20" name="TextBox 19"/>
           <p:cNvSpPr txBox="1"/>
           <p:nvPr/>
         </p:nvSpPr>
@@ -15212,7 +15332,7 @@
         <p:spPr>
           <a:xfrm>
             <a:off x="502920" y="292608"/>
-            <a:ext cx="11185855" cy="685800"/>
+            <a:ext cx="10408615" cy="685800"/>
           </a:xfrm>
           <a:prstGeom prst="rect">
             <a:avLst/>
@@ -15245,9 +15365,33 @@
           </a:p>
         </p:txBody>
       </p:sp>
+      <p:pic>
+        <p:nvPicPr>
+          <p:cNvPr id="3" name="Picture 2" descr="elevenlabs.png"/>
+          <p:cNvPicPr>
+            <a:picLocks noChangeAspect="1"/>
+          </p:cNvPicPr>
+          <p:nvPr/>
+        </p:nvPicPr>
+        <p:blipFill>
+          <a:blip r:embed="rId2"/>
+          <a:stretch>
+            <a:fillRect/>
+          </a:stretch>
+        </p:blipFill>
+        <p:spPr>
+          <a:xfrm>
+            <a:off x="11231575" y="274320"/>
+            <a:ext cx="457200" cy="457200"/>
+          </a:xfrm>
+          <a:prstGeom prst="rect">
+            <a:avLst/>
+          </a:prstGeom>
+        </p:spPr>
+      </p:pic>
       <p:cxnSp>
         <p:nvCxnSpPr>
-          <p:cNvPr id="3" name="Connector 2"/>
+          <p:cNvPr id="4" name="Connector 3"/>
           <p:cNvCxnSpPr/>
           <p:nvPr/>
         </p:nvCxnSpPr>
@@ -15269,7 +15413,7 @@
       </p:cxnSp>
       <p:sp>
         <p:nvSpPr>
-          <p:cNvPr id="4" name="TextBox 3"/>
+          <p:cNvPr id="5" name="TextBox 4"/>
           <p:cNvSpPr txBox="1"/>
           <p:nvPr/>
         </p:nvSpPr>
@@ -15311,7 +15455,7 @@
       </p:sp>
       <p:sp>
         <p:nvSpPr>
-          <p:cNvPr id="5" name="TextBox 4"/>
+          <p:cNvPr id="6" name="TextBox 5"/>
           <p:cNvSpPr txBox="1"/>
           <p:nvPr/>
         </p:nvSpPr>
@@ -15353,7 +15497,7 @@
       </p:sp>
       <p:cxnSp>
         <p:nvCxnSpPr>
-          <p:cNvPr id="6" name="Connector 5"/>
+          <p:cNvPr id="7" name="Connector 6"/>
           <p:cNvCxnSpPr/>
           <p:nvPr/>
         </p:nvCxnSpPr>
@@ -15375,7 +15519,7 @@
       </p:cxnSp>
       <p:sp>
         <p:nvSpPr>
-          <p:cNvPr id="7" name="TextBox 6"/>
+          <p:cNvPr id="8" name="TextBox 7"/>
           <p:cNvSpPr txBox="1"/>
           <p:nvPr/>
         </p:nvSpPr>
@@ -15454,7 +15598,7 @@
       </p:sp>
       <p:sp>
         <p:nvSpPr>
-          <p:cNvPr id="8" name="TextBox 7"/>
+          <p:cNvPr id="9" name="TextBox 8"/>
           <p:cNvSpPr txBox="1"/>
           <p:nvPr/>
         </p:nvSpPr>
@@ -15496,7 +15640,7 @@
       </p:sp>
       <p:cxnSp>
         <p:nvCxnSpPr>
-          <p:cNvPr id="9" name="Connector 8"/>
+          <p:cNvPr id="10" name="Connector 9"/>
           <p:cNvCxnSpPr/>
           <p:nvPr/>
         </p:nvCxnSpPr>
@@ -15518,7 +15662,7 @@
       </p:cxnSp>
       <p:sp>
         <p:nvSpPr>
-          <p:cNvPr id="10" name="TextBox 9"/>
+          <p:cNvPr id="11" name="TextBox 10"/>
           <p:cNvSpPr txBox="1"/>
           <p:nvPr/>
         </p:nvSpPr>
@@ -15597,7 +15741,7 @@
       </p:sp>
       <p:sp>
         <p:nvSpPr>
-          <p:cNvPr id="11" name="TextBox 10"/>
+          <p:cNvPr id="12" name="TextBox 11"/>
           <p:cNvSpPr txBox="1"/>
           <p:nvPr/>
         </p:nvSpPr>
@@ -15639,7 +15783,7 @@
       </p:sp>
       <p:cxnSp>
         <p:nvCxnSpPr>
-          <p:cNvPr id="12" name="Connector 11"/>
+          <p:cNvPr id="13" name="Connector 12"/>
           <p:cNvCxnSpPr/>
           <p:nvPr/>
         </p:nvCxnSpPr>
@@ -15661,7 +15805,7 @@
       </p:cxnSp>
       <p:sp>
         <p:nvSpPr>
-          <p:cNvPr id="13" name="TextBox 12"/>
+          <p:cNvPr id="14" name="TextBox 13"/>
           <p:cNvSpPr txBox="1"/>
           <p:nvPr/>
         </p:nvSpPr>
@@ -15740,7 +15884,7 @@
       </p:sp>
       <p:sp>
         <p:nvSpPr>
-          <p:cNvPr id="14" name="TextBox 13"/>
+          <p:cNvPr id="15" name="TextBox 14"/>
           <p:cNvSpPr txBox="1"/>
           <p:nvPr/>
         </p:nvSpPr>
@@ -15782,7 +15926,7 @@
       </p:sp>
       <p:cxnSp>
         <p:nvCxnSpPr>
-          <p:cNvPr id="15" name="Connector 14"/>
+          <p:cNvPr id="16" name="Connector 15"/>
           <p:cNvCxnSpPr/>
           <p:nvPr/>
         </p:nvCxnSpPr>
@@ -15804,7 +15948,7 @@
       </p:cxnSp>
       <p:sp>
         <p:nvSpPr>
-          <p:cNvPr id="16" name="TextBox 15"/>
+          <p:cNvPr id="17" name="TextBox 16"/>
           <p:cNvSpPr txBox="1"/>
           <p:nvPr/>
         </p:nvSpPr>
@@ -15883,7 +16027,7 @@
       </p:sp>
       <p:cxnSp>
         <p:nvCxnSpPr>
-          <p:cNvPr id="17" name="Connector 16"/>
+          <p:cNvPr id="18" name="Connector 17"/>
           <p:cNvCxnSpPr/>
           <p:nvPr/>
         </p:nvCxnSpPr>
@@ -15905,7 +16049,7 @@
       </p:cxnSp>
       <p:sp>
         <p:nvSpPr>
-          <p:cNvPr id="18" name="TextBox 17"/>
+          <p:cNvPr id="19" name="TextBox 18"/>
           <p:cNvSpPr txBox="1"/>
           <p:nvPr/>
         </p:nvSpPr>
@@ -15947,7 +16091,7 @@
       </p:sp>
       <p:sp>
         <p:nvSpPr>
-          <p:cNvPr id="19" name="TextBox 18"/>
+          <p:cNvPr id="20" name="TextBox 19"/>
           <p:cNvSpPr txBox="1"/>
           <p:nvPr/>
         </p:nvSpPr>

</xml_diff>